<commit_message>
Update egress presentation and documentation to reflect recent findings and next steps. Revised key points in the slides to clarify the current status of the EKS cluster connectivity and the need to synchronize the public key. Enhanced HALLAZGOS.md to document the successful validation against the real destination and the implications of the current configuration. Updated README to emphasize the importance of the public key synchronization and its impact on the migration process.
</commit_message>
<xml_diff>
--- a/poc-egress-kuadrant/poc-egreso-kuadrant-gerencial-2026-08.pptx
+++ b/poc-egress-kuadrant/poc-egreso-kuadrant-gerencial-2026-08.pptx
@@ -3474,7 +3474,7 @@
                 <a:ea typeface="Calibri" pitchFamily="34" charset="-122"/>
                 <a:cs typeface="Calibri" pitchFamily="34" charset="-120"/>
               </a:rPr>
-              <a:t>EL ÚNICO BLOQUEANTE</a:t>
+              <a:t>LO ÚNICO QUE FALTA</a:t>
             </a:r>
             <a:endParaRPr lang="en-US" sz="1300" dirty="0"/>
           </a:p>
@@ -3516,7 +3516,7 @@
                 <a:ea typeface="Cambria" pitchFamily="34" charset="-122"/>
                 <a:cs typeface="Cambria" pitchFamily="34" charset="-120"/>
               </a:rPr>
-              <a:t>No hay camino de red</a:t>
+              <a:t>Sincronizar una clave</a:t>
             </a:r>
             <a:endParaRPr lang="en-US" sz="3800" dirty="0"/>
           </a:p>
@@ -3536,7 +3536,7 @@
                 <a:ea typeface="Cambria" pitchFamily="34" charset="-122"/>
                 <a:cs typeface="Cambria" pitchFamily="34" charset="-120"/>
               </a:rPr>
-              <a:t>hacia el cluster destino</a:t>
+              <a:t>en el cluster destino</a:t>
             </a:r>
             <a:endParaRPr lang="en-US" sz="3800" dirty="0"/>
           </a:p>
@@ -3578,7 +3578,7 @@
                 <a:ea typeface="Calibri" pitchFamily="34" charset="-122"/>
                 <a:cs typeface="Calibri" pitchFamily="34" charset="-120"/>
               </a:rPr>
-              <a:t>El nombre resuelve y no hay proxy en el medio, pero las conexiones al cluster de AWS no llegan — ni desde los servidores ni desde el bastión. Es un pedido de habilitación a la red corporativa, no un problema de la plataforma.</a:t>
+              <a:t>El cluster destino ya está desplegado, es alcanzable desde el origen y su control de acceso está activo. Pero la clave pública que tiene cargada quedó de una versión anterior de la prueba, así que todavía rechaza las credenciales que emitimos.</a:t>
             </a:r>
             <a:endParaRPr lang="en-US" sz="1600" dirty="0"/>
           </a:p>
@@ -3651,7 +3651,7 @@
                 <a:ea typeface="Cambria" pitchFamily="34" charset="-122"/>
                 <a:cs typeface="Cambria" pitchFamily="34" charset="-120"/>
               </a:rPr>
-              <a:t>Mientras tanto, la prueba se completó contra un destino simulado dentro del mismo cluster.</a:t>
+              <a:t>Es un cambio de configuración de minutos, y no depende de nuestro equipo.</a:t>
             </a:r>
             <a:endParaRPr lang="en-US" sz="1600" dirty="0"/>
           </a:p>
@@ -3693,7 +3693,7 @@
                 <a:ea typeface="Calibri" pitchFamily="34" charset="-122"/>
                 <a:cs typeface="Calibri" pitchFamily="34" charset="-120"/>
               </a:rPr>
-              <a:t>Eso permitió validar todo salvo la latencia entre clusters y la diferencia de reloj entre ellos. Ambas quedan pendientes de la habilitación de red.</a:t>
+              <a:t>La prueba se completó contra un destino simulado dentro del mismo cluster, lo que permitió validar todo salvo la latencia entre clusters y la diferencia de reloj entre ellos.</a:t>
             </a:r>
             <a:endParaRPr lang="en-US" sz="1400" dirty="0"/>
           </a:p>
@@ -4080,7 +4080,7 @@
                 <a:ea typeface="Cambria" pitchFamily="34" charset="-122"/>
                 <a:cs typeface="Cambria" pitchFamily="34" charset="-120"/>
               </a:rPr>
-              <a:t>Pedir la habilitación de red</a:t>
+              <a:t>Cerrar la prueba con el cluster real</a:t>
             </a:r>
             <a:endParaRPr lang="en-US" sz="1800" dirty="0"/>
           </a:p>
@@ -4122,7 +4122,7 @@
                 <a:ea typeface="Calibri" pitchFamily="34" charset="-122"/>
                 <a:cs typeface="Calibri" pitchFamily="34" charset="-120"/>
               </a:rPr>
-              <a:t>Es el único bloqueante para completar la prueba con el cluster real. Sin eso no se puede medir latencia ni programar la migración.</a:t>
+              <a:t>Pedir la sincronización de la clave en el destino. Es lo único que falta para medir latencia real y programar la migración.</a:t>
             </a:r>
             <a:endParaRPr lang="en-US" sz="1350" dirty="0"/>
           </a:p>

</xml_diff>